<commit_message>
Update Project Slides & Video
</commit_message>
<xml_diff>
--- a/Project Slides/project-slides-final.pptx
+++ b/Project Slides/project-slides-final.pptx
@@ -4597,7 +4597,29 @@
                 <a:ea typeface="Calibri" pitchFamily="34" charset="-122"/>
                 <a:cs typeface="Calibri" pitchFamily="34" charset="-120"/>
               </a:rPr>
-              <a:t>PostgreSQL  |  Cloud / Local Storage  |  CSV Export</a:t>
+              <a:t>PostgreSQL  |  Cloud / Local Storage  |  </a:t>
+            </a:r>
+            <a:r>
+              <a:rPr lang="en-US" sz="1200" dirty="0" smtClean="0">
+                <a:solidFill>
+                  <a:srgbClr val="1A2E35"/>
+                </a:solidFill>
+                <a:latin typeface="Calibri" pitchFamily="34" charset="0"/>
+                <a:ea typeface="Calibri" pitchFamily="34" charset="-122"/>
+                <a:cs typeface="Calibri" pitchFamily="34" charset="-120"/>
+              </a:rPr>
+              <a:t>PDF </a:t>
+            </a:r>
+            <a:r>
+              <a:rPr lang="en-US" sz="1200" dirty="0">
+                <a:solidFill>
+                  <a:srgbClr val="1A2E35"/>
+                </a:solidFill>
+                <a:latin typeface="Calibri" pitchFamily="34" charset="0"/>
+                <a:ea typeface="Calibri" pitchFamily="34" charset="-122"/>
+                <a:cs typeface="Calibri" pitchFamily="34" charset="-120"/>
+              </a:rPr>
+              <a:t>Export</a:t>
             </a:r>
             <a:endParaRPr lang="en-US" sz="1200" dirty="0"/>
           </a:p>
@@ -4900,7 +4922,7 @@
                 <a:ea typeface="Calibri" pitchFamily="34" charset="-122"/>
                 <a:cs typeface="Calibri" pitchFamily="34" charset="-120"/>
               </a:rPr>
-              <a:t>Git / GitHub  |  Netlify (Frontend)  |  Linux Server (Backend)</a:t>
+              <a:t>Git / GitHub  </a:t>
             </a:r>
             <a:endParaRPr lang="en-US" sz="1200" dirty="0"/>
           </a:p>
@@ -7548,18 +7570,7 @@
                 <a:ea typeface="Trebuchet MS" pitchFamily="34" charset="-122"/>
                 <a:cs typeface="Trebuchet MS" pitchFamily="34" charset="-120"/>
               </a:rPr>
-              <a:t>Doctor</a:t>
-            </a:r>
-            <a:r>
-              <a:rPr lang="en-US" sz="1600" b="1" dirty="0" smtClean="0">
-                <a:solidFill>
-                  <a:srgbClr val="FFFFFF"/>
-                </a:solidFill>
-                <a:latin typeface="Trebuchet MS" pitchFamily="34" charset="0"/>
-                <a:ea typeface="Trebuchet MS" pitchFamily="34" charset="-122"/>
-                <a:cs typeface="Trebuchet MS" pitchFamily="34" charset="-120"/>
-              </a:rPr>
-              <a:t> Dashboard</a:t>
+              <a:t>Doctor Dashboard</a:t>
             </a:r>
             <a:endParaRPr lang="en-US" sz="1600" dirty="0"/>
           </a:p>
@@ -8029,18 +8040,7 @@
                 <a:ea typeface="Trebuchet MS" pitchFamily="34" charset="-122"/>
                 <a:cs typeface="Trebuchet MS" pitchFamily="34" charset="-120"/>
               </a:rPr>
-              <a:t>Admin</a:t>
-            </a:r>
-            <a:r>
-              <a:rPr lang="en-US" sz="1600" b="1" dirty="0" smtClean="0">
-                <a:solidFill>
-                  <a:srgbClr val="FFFFFF"/>
-                </a:solidFill>
-                <a:latin typeface="Trebuchet MS" pitchFamily="34" charset="0"/>
-                <a:ea typeface="Trebuchet MS" pitchFamily="34" charset="-122"/>
-                <a:cs typeface="Trebuchet MS" pitchFamily="34" charset="-120"/>
-              </a:rPr>
-              <a:t> Dashboard</a:t>
+              <a:t>Admin Dashboard</a:t>
             </a:r>
             <a:endParaRPr lang="en-US" sz="1600" dirty="0"/>
           </a:p>
@@ -14957,7 +14957,40 @@
                 <a:ea typeface="Calibri" pitchFamily="34" charset="-122"/>
                 <a:cs typeface="Calibri" pitchFamily="34" charset="-120"/>
               </a:rPr>
-              <a:t>Depends on Whisper AI &amp; spaCy APIs; service interruptions affect accuracy.</a:t>
+              <a:t>Depends on </a:t>
+            </a:r>
+            <a:r>
+              <a:rPr lang="en-US" sz="1200" dirty="0" err="1" smtClean="0">
+                <a:solidFill>
+                  <a:srgbClr val="1A2E35"/>
+                </a:solidFill>
+                <a:latin typeface="Calibri" pitchFamily="34" charset="0"/>
+                <a:ea typeface="Calibri" pitchFamily="34" charset="-122"/>
+                <a:cs typeface="Calibri" pitchFamily="34" charset="-120"/>
+              </a:rPr>
+              <a:t>Deegram</a:t>
+            </a:r>
+            <a:r>
+              <a:rPr lang="en-US" sz="1200" dirty="0" smtClean="0">
+                <a:solidFill>
+                  <a:srgbClr val="1A2E35"/>
+                </a:solidFill>
+                <a:latin typeface="Calibri" pitchFamily="34" charset="0"/>
+                <a:ea typeface="Calibri" pitchFamily="34" charset="-122"/>
+                <a:cs typeface="Calibri" pitchFamily="34" charset="-120"/>
+              </a:rPr>
+              <a:t> &amp; OPENAI GPT 4.1; </a:t>
+            </a:r>
+            <a:r>
+              <a:rPr lang="en-US" sz="1200" dirty="0">
+                <a:solidFill>
+                  <a:srgbClr val="1A2E35"/>
+                </a:solidFill>
+                <a:latin typeface="Calibri" pitchFamily="34" charset="0"/>
+                <a:ea typeface="Calibri" pitchFamily="34" charset="-122"/>
+                <a:cs typeface="Calibri" pitchFamily="34" charset="-120"/>
+              </a:rPr>
+              <a:t>service interruptions affect accuracy.</a:t>
             </a:r>
             <a:endParaRPr lang="en-US" sz="1200" dirty="0"/>
           </a:p>

</xml_diff>